<commit_message>
Sales: Marktüberblick weiterer PIM-Systeme als Schlussfolie der Kostenbetrachtung
Stibo STEP, Centric PXM (ehem. Contentserv) und Akeneo: Einschätzung,
Passung für Kohlhammer und grober Kostenindikator; incoxx berät, implementiert
diese Systeme aber nicht.

Co-Authored-By: Claude Opus 5.5 <noreply@anthropic.com>
Claude-Session: https://claude.ai/code/session_019qs2qjmit64azXVvXyRtsJ
</commit_message>
<xml_diff>
--- a/docs/sales/kohlhammer-pim-kostenbetrachtung.pptx
+++ b/docs/sales/kohlhammer-pim-kostenbetrachtung.pptx
@@ -18,9 +18,10 @@
     <p:sldId id="266" r:id="rId12"/>
     <p:sldId id="267" r:id="rId13"/>
     <p:sldId id="268" r:id="rId14"/>
+    <p:sldId id="269" r:id="rId15"/>
   </p:sldIdLst>
   <p:notesMasterIdLst>
-    <p:notesMasterId r:id="rId15"/>
+    <p:notesMasterId r:id="rId16"/>
   </p:notesMasterIdLst>
   <p:sldSz cx="12192000" cy="6858000"/>
   <p:notesSz cx="6858000" cy="12192000"/>
@@ -1346,6 +1347,94 @@
             <a:fld id="{F7021451-1387-4CA6-816F-3879F97B5CBC}" type="slidenum">
               <a:rPr lang="en-US"/>
               <a:t>13</a:t>
+            </a:fld>
+            <a:endParaRPr lang="en-US"/>
+          </a:p>
+        </p:txBody>
+      </p:sp>
+    </p:spTree>
+    <p:extLst>
+      <p:ext uri="{BB962C8B-B14F-4D97-AF65-F5344CB8AC3E}">
+        <p14:creationId xmlns:p14="http://schemas.microsoft.com/office/powerpoint/2010/main" val="1024086991"/>
+      </p:ext>
+    </p:extLst>
+  </p:cSld>
+  <p:clrMapOvr>
+    <a:masterClrMapping/>
+  </p:clrMapOvr>
+</p:notes>
+</file>
+
+<file path=ppt/notesSlides/notesSlide14.xml><?xml version="1.0" encoding="utf-8"?>
+<p:notes xmlns:a="http://schemas.openxmlformats.org/drawingml/2006/main" xmlns:r="http://schemas.openxmlformats.org/officeDocument/2006/relationships" xmlns:p="http://schemas.openxmlformats.org/presentationml/2006/main">
+  <p:cSld>
+    <p:spTree>
+      <p:nvGrpSpPr>
+        <p:cNvPr id="1" name=""/>
+        <p:cNvGrpSpPr/>
+        <p:nvPr/>
+      </p:nvGrpSpPr>
+      <p:grpSpPr>
+        <a:xfrm>
+          <a:off x="0" y="0"/>
+          <a:ext cx="0" cy="0"/>
+          <a:chOff x="0" y="0"/>
+          <a:chExt cx="0" cy="0"/>
+        </a:xfrm>
+      </p:grpSpPr>
+      <p:sp>
+        <p:nvSpPr>
+          <p:cNvPr id="2" name="Slide Image Placeholder 1"/>
+          <p:cNvSpPr>
+            <a:spLocks noGrp="1" noRot="1" noChangeAspect="1"/>
+          </p:cNvSpPr>
+          <p:nvPr>
+            <p:ph type="sldImg"/>
+          </p:nvPr>
+        </p:nvSpPr>
+        <p:spPr/>
+      </p:sp>
+      <p:sp>
+        <p:nvSpPr>
+          <p:cNvPr id="3" name="Notes Placeholder 2"/>
+          <p:cNvSpPr>
+            <a:spLocks noGrp="1"/>
+          </p:cNvSpPr>
+          <p:nvPr>
+            <p:ph type="body" idx="1"/>
+          </p:nvPr>
+        </p:nvSpPr>
+        <p:spPr/>
+        <p:txBody>
+          <a:bodyPr/>
+          <a:lstStyle/>
+          <a:p>
+            <a:r>
+              <a:rPr lang="en-US" dirty="0"/>
+              <a:t>Marktüberblick für die Vollständigkeit. Alle drei sind etablierte Systeme mit eigenem Partnernetz; incoxx berät bei der Auswahl, implementiert sie aber nicht – das macht die Einordnung unabhängig. Für das Profil von Kohlhammer (Titeldaten, Print-Ausgaben, schlanker Betrieb) liegen Stibo und Centric PXM tendenziell über dem nötigen Umfang und Budget; Akeneo ist stark im E-Commerce, Print braucht Zusatzarbeit. Kostenangaben sind grobe Größenordnungen.</a:t>
+            </a:r>
+            <a:endParaRPr lang="en-US" dirty="0"/>
+          </a:p>
+        </p:txBody>
+      </p:sp>
+      <p:sp>
+        <p:nvSpPr>
+          <p:cNvPr id="4" name="Slide Number Placeholder 3"/>
+          <p:cNvSpPr>
+            <a:spLocks noGrp="1"/>
+          </p:cNvSpPr>
+          <p:nvPr>
+            <p:ph type="sldNum" sz="quarter" idx="10"/>
+          </p:nvPr>
+        </p:nvSpPr>
+        <p:spPr/>
+        <p:txBody>
+          <a:bodyPr/>
+          <a:lstStyle/>
+          <a:p>
+            <a:fld id="{F7021451-1387-4CA6-816F-3879F97B5CBC}" type="slidenum">
+              <a:rPr lang="en-US"/>
+              <a:t>14</a:t>
             </a:fld>
             <a:endParaRPr lang="en-US"/>
           </a:p>
@@ -10031,6 +10120,1401 @@
 </p:sld>
 </file>
 
+<file path=ppt/slides/slide14.xml><?xml version="1.0" encoding="utf-8"?>
+<p:sld xmlns:a="http://schemas.openxmlformats.org/drawingml/2006/main" xmlns:r="http://schemas.openxmlformats.org/officeDocument/2006/relationships" xmlns:p="http://schemas.openxmlformats.org/presentationml/2006/main">
+  <p:cSld name="Slide 14">
+    <p:bg>
+      <p:bgPr>
+        <a:solidFill>
+          <a:srgbClr val="FFFFFF"/>
+        </a:solidFill>
+      </p:bgPr>
+    </p:bg>
+    <p:spTree>
+      <p:nvGrpSpPr>
+        <p:cNvPr id="1" name=""/>
+        <p:cNvGrpSpPr/>
+        <p:nvPr/>
+      </p:nvGrpSpPr>
+      <p:grpSpPr>
+        <a:xfrm>
+          <a:off x="0" y="0"/>
+          <a:ext cx="0" cy="0"/>
+          <a:chOff x="0" y="0"/>
+          <a:chExt cx="0" cy="0"/>
+        </a:xfrm>
+      </p:grpSpPr>
+      <p:sp>
+        <p:nvSpPr>
+          <p:cNvPr id="2" name="Text 0"/>
+          <p:cNvSpPr txBox="1"/>
+          <p:nvPr/>
+        </p:nvSpPr>
+        <p:spPr>
+          <a:xfrm>
+            <a:off x="548640" y="411480"/>
+            <a:ext cx="11094415" cy="594360"/>
+          </a:xfrm>
+          <a:prstGeom prst="rect">
+            <a:avLst/>
+          </a:prstGeom>
+          <a:noFill/>
+          <a:ln/>
+        </p:spPr>
+        <p:txBody>
+          <a:bodyPr wrap="square" lIns="0" tIns="0" rIns="0" bIns="0" rtlCol="0" anchor="b"/>
+          <a:lstStyle/>
+          <a:p>
+            <a:pPr indent="0" marL="0">
+              <a:buNone/>
+            </a:pPr>
+            <a:r>
+              <a:rPr lang="en-US" sz="3000" dirty="0">
+                <a:solidFill>
+                  <a:srgbClr val="16181D"/>
+                </a:solidFill>
+                <a:latin typeface="Arial" pitchFamily="34" charset="0"/>
+                <a:ea typeface="Arial" pitchFamily="34" charset="-122"/>
+                <a:cs typeface="Arial" pitchFamily="34" charset="-120"/>
+              </a:rPr>
+              <a:t>WEITERE PIM-SYSTEME AM MARKT</a:t>
+            </a:r>
+            <a:endParaRPr lang="en-US" sz="3000" dirty="0"/>
+          </a:p>
+        </p:txBody>
+      </p:sp>
+      <p:sp>
+        <p:nvSpPr>
+          <p:cNvPr id="3" name="Text 1"/>
+          <p:cNvSpPr txBox="1"/>
+          <p:nvPr/>
+        </p:nvSpPr>
+        <p:spPr>
+          <a:xfrm>
+            <a:off x="548640" y="1033272"/>
+            <a:ext cx="11094415" cy="365760"/>
+          </a:xfrm>
+          <a:prstGeom prst="rect">
+            <a:avLst/>
+          </a:prstGeom>
+          <a:noFill/>
+          <a:ln/>
+        </p:spPr>
+        <p:txBody>
+          <a:bodyPr wrap="square" lIns="0" tIns="0" rIns="0" bIns="0" rtlCol="0" anchor="t"/>
+          <a:lstStyle/>
+          <a:p>
+            <a:pPr indent="0" marL="0">
+              <a:buNone/>
+            </a:pPr>
+            <a:r>
+              <a:rPr lang="en-US" sz="1400" dirty="0">
+                <a:solidFill>
+                  <a:srgbClr val="4B5563"/>
+                </a:solidFill>
+                <a:latin typeface="Arial" pitchFamily="34" charset="0"/>
+                <a:ea typeface="Arial" pitchFamily="34" charset="-122"/>
+                <a:cs typeface="Arial" pitchFamily="34" charset="-120"/>
+              </a:rPr>
+              <a:t>Kurze Einordnung. incoxx berät bei Auswahl und Anforderungen – implementiert diese Systeme aber nicht.</a:t>
+            </a:r>
+            <a:endParaRPr lang="en-US" sz="1400" dirty="0"/>
+          </a:p>
+        </p:txBody>
+      </p:sp>
+      <p:sp>
+        <p:nvSpPr>
+          <p:cNvPr id="4" name="Text 2"/>
+          <p:cNvSpPr txBox="1"/>
+          <p:nvPr/>
+        </p:nvSpPr>
+        <p:spPr>
+          <a:xfrm>
+            <a:off x="548640" y="6400800"/>
+            <a:ext cx="7315200" cy="228600"/>
+          </a:xfrm>
+          <a:prstGeom prst="rect">
+            <a:avLst/>
+          </a:prstGeom>
+          <a:noFill/>
+          <a:ln/>
+        </p:spPr>
+        <p:txBody>
+          <a:bodyPr wrap="square" lIns="0" tIns="0" rIns="0" bIns="0" rtlCol="0" anchor="t"/>
+          <a:lstStyle/>
+          <a:p>
+            <a:pPr indent="0" marL="0">
+              <a:buNone/>
+            </a:pPr>
+            <a:r>
+              <a:rPr lang="en-US" sz="900" dirty="0">
+                <a:solidFill>
+                  <a:srgbClr val="4B5563"/>
+                </a:solidFill>
+                <a:latin typeface="Arial" pitchFamily="34" charset="0"/>
+                <a:ea typeface="Arial" pitchFamily="34" charset="-122"/>
+                <a:cs typeface="Arial" pitchFamily="34" charset="-120"/>
+              </a:rPr>
+              <a:t>PIM-Kostenbetrachtung Kohlhammer  ·  Entscheidungsgrundlage  ·  September 2026</a:t>
+            </a:r>
+            <a:endParaRPr lang="en-US" sz="900" dirty="0"/>
+          </a:p>
+        </p:txBody>
+      </p:sp>
+      <p:sp>
+        <p:nvSpPr>
+          <p:cNvPr id="5" name="Text 3"/>
+          <p:cNvSpPr txBox="1"/>
+          <p:nvPr/>
+        </p:nvSpPr>
+        <p:spPr>
+          <a:xfrm>
+            <a:off x="10728655" y="6400800"/>
+            <a:ext cx="914400" cy="228600"/>
+          </a:xfrm>
+          <a:prstGeom prst="rect">
+            <a:avLst/>
+          </a:prstGeom>
+          <a:noFill/>
+          <a:ln/>
+        </p:spPr>
+        <p:txBody>
+          <a:bodyPr wrap="square" lIns="0" tIns="0" rIns="0" bIns="0" rtlCol="0" anchor="t"/>
+          <a:lstStyle/>
+          <a:p>
+            <a:pPr algn="r" indent="0" marL="0">
+              <a:buNone/>
+            </a:pPr>
+            <a:r>
+              <a:rPr lang="en-US" sz="900" dirty="0">
+                <a:solidFill>
+                  <a:srgbClr val="4B5563"/>
+                </a:solidFill>
+                <a:latin typeface="Arial" pitchFamily="34" charset="0"/>
+                <a:ea typeface="Arial" pitchFamily="34" charset="-122"/>
+                <a:cs typeface="Arial" pitchFamily="34" charset="-120"/>
+              </a:rPr>
+              <a:t>14</a:t>
+            </a:r>
+            <a:endParaRPr lang="en-US" sz="900" dirty="0"/>
+          </a:p>
+        </p:txBody>
+      </p:sp>
+      <p:sp>
+        <p:nvSpPr>
+          <p:cNvPr id="6" name="Shape 4"/>
+          <p:cNvSpPr/>
+          <p:nvPr/>
+        </p:nvSpPr>
+        <p:spPr>
+          <a:xfrm>
+            <a:off x="548640" y="1645920"/>
+            <a:ext cx="3520440" cy="868680"/>
+          </a:xfrm>
+          <a:prstGeom prst="rect">
+            <a:avLst/>
+          </a:prstGeom>
+          <a:solidFill>
+            <a:srgbClr val="1B2D5C"/>
+          </a:solidFill>
+          <a:ln w="12700">
+            <a:solidFill>
+              <a:srgbClr val="1B2D5C"/>
+            </a:solidFill>
+            <a:prstDash val="solid"/>
+          </a:ln>
+        </p:spPr>
+      </p:sp>
+      <p:sp>
+        <p:nvSpPr>
+          <p:cNvPr id="7" name="Text 5"/>
+          <p:cNvSpPr txBox="1"/>
+          <p:nvPr/>
+        </p:nvSpPr>
+        <p:spPr>
+          <a:xfrm>
+            <a:off x="777240" y="1737360"/>
+            <a:ext cx="3063240" cy="384048"/>
+          </a:xfrm>
+          <a:prstGeom prst="rect">
+            <a:avLst/>
+          </a:prstGeom>
+          <a:noFill/>
+          <a:ln/>
+        </p:spPr>
+        <p:txBody>
+          <a:bodyPr wrap="square" lIns="0" tIns="0" rIns="0" bIns="0" rtlCol="0" anchor="ctr"/>
+          <a:lstStyle/>
+          <a:p>
+            <a:pPr indent="0" marL="0">
+              <a:buNone/>
+            </a:pPr>
+            <a:r>
+              <a:rPr lang="en-US" sz="1600" b="1" dirty="0">
+                <a:solidFill>
+                  <a:srgbClr val="FFFFFF"/>
+                </a:solidFill>
+                <a:latin typeface="Arial" pitchFamily="34" charset="0"/>
+                <a:ea typeface="Arial" pitchFamily="34" charset="-122"/>
+                <a:cs typeface="Arial" pitchFamily="34" charset="-120"/>
+              </a:rPr>
+              <a:t>Stibo Systems STEP</a:t>
+            </a:r>
+            <a:endParaRPr lang="en-US" sz="1600" dirty="0"/>
+          </a:p>
+        </p:txBody>
+      </p:sp>
+      <p:sp>
+        <p:nvSpPr>
+          <p:cNvPr id="8" name="Text 6"/>
+          <p:cNvSpPr txBox="1"/>
+          <p:nvPr/>
+        </p:nvSpPr>
+        <p:spPr>
+          <a:xfrm>
+            <a:off x="777240" y="2103120"/>
+            <a:ext cx="3063240" cy="365760"/>
+          </a:xfrm>
+          <a:prstGeom prst="rect">
+            <a:avLst/>
+          </a:prstGeom>
+          <a:noFill/>
+          <a:ln/>
+        </p:spPr>
+        <p:txBody>
+          <a:bodyPr wrap="square" lIns="0" tIns="0" rIns="0" bIns="0" rtlCol="0" anchor="t"/>
+          <a:lstStyle/>
+          <a:p>
+            <a:pPr indent="0" marL="0">
+              <a:buNone/>
+            </a:pPr>
+            <a:r>
+              <a:rPr lang="en-US" sz="1100" dirty="0">
+                <a:solidFill>
+                  <a:srgbClr val="C6E6E3"/>
+                </a:solidFill>
+                <a:latin typeface="Arial" pitchFamily="34" charset="0"/>
+                <a:ea typeface="Arial" pitchFamily="34" charset="-122"/>
+                <a:cs typeface="Arial" pitchFamily="34" charset="-120"/>
+              </a:rPr>
+              <a:t>Multidomain-MDM für Großunternehmen</a:t>
+            </a:r>
+            <a:endParaRPr lang="en-US" sz="1100" dirty="0"/>
+          </a:p>
+        </p:txBody>
+      </p:sp>
+      <p:sp>
+        <p:nvSpPr>
+          <p:cNvPr id="9" name="Shape 7"/>
+          <p:cNvSpPr/>
+          <p:nvPr/>
+        </p:nvSpPr>
+        <p:spPr>
+          <a:xfrm>
+            <a:off x="548640" y="2514600"/>
+            <a:ext cx="3520440" cy="2880360"/>
+          </a:xfrm>
+          <a:prstGeom prst="rect">
+            <a:avLst/>
+          </a:prstGeom>
+          <a:solidFill>
+            <a:srgbClr val="FFFFFF"/>
+          </a:solidFill>
+          <a:ln w="12700">
+            <a:solidFill>
+              <a:srgbClr val="D6DDE3"/>
+            </a:solidFill>
+            <a:prstDash val="solid"/>
+          </a:ln>
+        </p:spPr>
+      </p:sp>
+      <p:sp>
+        <p:nvSpPr>
+          <p:cNvPr id="10" name="Text 8"/>
+          <p:cNvSpPr txBox="1"/>
+          <p:nvPr/>
+        </p:nvSpPr>
+        <p:spPr>
+          <a:xfrm>
+            <a:off x="777240" y="2651760"/>
+            <a:ext cx="3063240" cy="228600"/>
+          </a:xfrm>
+          <a:prstGeom prst="rect">
+            <a:avLst/>
+          </a:prstGeom>
+          <a:noFill/>
+          <a:ln/>
+        </p:spPr>
+        <p:txBody>
+          <a:bodyPr wrap="square" lIns="0" tIns="0" rIns="0" bIns="0" rtlCol="0" anchor="t"/>
+          <a:lstStyle/>
+          <a:p>
+            <a:pPr indent="0" marL="0">
+              <a:buNone/>
+            </a:pPr>
+            <a:r>
+              <a:rPr lang="en-US" sz="1000" b="1" spc="100" kern="0" dirty="0">
+                <a:solidFill>
+                  <a:srgbClr val="4B5563"/>
+                </a:solidFill>
+                <a:latin typeface="Arial" pitchFamily="34" charset="0"/>
+                <a:ea typeface="Arial" pitchFamily="34" charset="-122"/>
+                <a:cs typeface="Arial" pitchFamily="34" charset="-120"/>
+              </a:rPr>
+              <a:t>EINSCHÄTZUNG</a:t>
+            </a:r>
+            <a:endParaRPr lang="en-US" sz="1000" dirty="0"/>
+          </a:p>
+        </p:txBody>
+      </p:sp>
+      <p:sp>
+        <p:nvSpPr>
+          <p:cNvPr id="11" name="Text 9"/>
+          <p:cNvSpPr txBox="1"/>
+          <p:nvPr/>
+        </p:nvSpPr>
+        <p:spPr>
+          <a:xfrm>
+            <a:off x="777240" y="2907792"/>
+            <a:ext cx="3063240" cy="960120"/>
+          </a:xfrm>
+          <a:prstGeom prst="rect">
+            <a:avLst/>
+          </a:prstGeom>
+          <a:noFill/>
+          <a:ln/>
+        </p:spPr>
+        <p:txBody>
+          <a:bodyPr wrap="square" lIns="0" tIns="0" rIns="0" bIns="0" rtlCol="0" anchor="t"/>
+          <a:lstStyle/>
+          <a:p>
+            <a:pPr indent="0" marL="0">
+              <a:lnSpc>
+                <a:spcPct val="108000"/>
+              </a:lnSpc>
+              <a:buNone/>
+            </a:pPr>
+            <a:r>
+              <a:rPr lang="en-US" sz="1200" dirty="0">
+                <a:solidFill>
+                  <a:srgbClr val="16181D"/>
+                </a:solidFill>
+                <a:latin typeface="Arial" pitchFamily="34" charset="0"/>
+                <a:ea typeface="Arial" pitchFamily="34" charset="-122"/>
+                <a:cs typeface="Arial" pitchFamily="34" charset="-120"/>
+              </a:rPr>
+              <a:t>Sehr umfassendes Stammdatenmanagement über Produkte, Lieferanten, Kunden und Standorte hinweg; stark in Governance und Datenqualität.</a:t>
+            </a:r>
+            <a:endParaRPr lang="en-US" sz="1200" dirty="0"/>
+          </a:p>
+        </p:txBody>
+      </p:sp>
+      <p:sp>
+        <p:nvSpPr>
+          <p:cNvPr id="12" name="Text 10"/>
+          <p:cNvSpPr txBox="1"/>
+          <p:nvPr/>
+        </p:nvSpPr>
+        <p:spPr>
+          <a:xfrm>
+            <a:off x="777240" y="3913632"/>
+            <a:ext cx="3063240" cy="228600"/>
+          </a:xfrm>
+          <a:prstGeom prst="rect">
+            <a:avLst/>
+          </a:prstGeom>
+          <a:noFill/>
+          <a:ln/>
+        </p:spPr>
+        <p:txBody>
+          <a:bodyPr wrap="square" lIns="0" tIns="0" rIns="0" bIns="0" rtlCol="0" anchor="t"/>
+          <a:lstStyle/>
+          <a:p>
+            <a:pPr indent="0" marL="0">
+              <a:buNone/>
+            </a:pPr>
+            <a:r>
+              <a:rPr lang="en-US" sz="1000" b="1" spc="100" kern="0" dirty="0">
+                <a:solidFill>
+                  <a:srgbClr val="4B5563"/>
+                </a:solidFill>
+                <a:latin typeface="Arial" pitchFamily="34" charset="0"/>
+                <a:ea typeface="Arial" pitchFamily="34" charset="-122"/>
+                <a:cs typeface="Arial" pitchFamily="34" charset="-120"/>
+              </a:rPr>
+              <a:t>PASSUNG FÜR KOHLHAMMER</a:t>
+            </a:r>
+            <a:endParaRPr lang="en-US" sz="1000" dirty="0"/>
+          </a:p>
+        </p:txBody>
+      </p:sp>
+      <p:sp>
+        <p:nvSpPr>
+          <p:cNvPr id="13" name="Text 11"/>
+          <p:cNvSpPr txBox="1"/>
+          <p:nvPr/>
+        </p:nvSpPr>
+        <p:spPr>
+          <a:xfrm>
+            <a:off x="777240" y="4169664"/>
+            <a:ext cx="3063240" cy="685800"/>
+          </a:xfrm>
+          <a:prstGeom prst="rect">
+            <a:avLst/>
+          </a:prstGeom>
+          <a:noFill/>
+          <a:ln/>
+        </p:spPr>
+        <p:txBody>
+          <a:bodyPr wrap="square" lIns="0" tIns="0" rIns="0" bIns="0" rtlCol="0" anchor="t"/>
+          <a:lstStyle/>
+          <a:p>
+            <a:pPr indent="0" marL="0">
+              <a:lnSpc>
+                <a:spcPct val="108000"/>
+              </a:lnSpc>
+              <a:buNone/>
+            </a:pPr>
+            <a:r>
+              <a:rPr lang="en-US" sz="1200" dirty="0">
+                <a:solidFill>
+                  <a:srgbClr val="16181D"/>
+                </a:solidFill>
+                <a:latin typeface="Arial" pitchFamily="34" charset="0"/>
+                <a:ea typeface="Arial" pitchFamily="34" charset="-122"/>
+                <a:cs typeface="Arial" pitchFamily="34" charset="-120"/>
+              </a:rPr>
+              <a:t>Für die Datenmenge und Struktur eines Fachverlags meist überdimensioniert.</a:t>
+            </a:r>
+            <a:endParaRPr lang="en-US" sz="1200" dirty="0"/>
+          </a:p>
+        </p:txBody>
+      </p:sp>
+      <p:sp>
+        <p:nvSpPr>
+          <p:cNvPr id="14" name="Shape 12"/>
+          <p:cNvSpPr/>
+          <p:nvPr/>
+        </p:nvSpPr>
+        <p:spPr>
+          <a:xfrm>
+            <a:off x="777240" y="4892040"/>
+            <a:ext cx="3063240" cy="0"/>
+          </a:xfrm>
+          <a:prstGeom prst="line">
+            <a:avLst/>
+          </a:prstGeom>
+          <a:noFill/>
+          <a:ln w="12700">
+            <a:solidFill>
+              <a:srgbClr val="D6DDE3"/>
+            </a:solidFill>
+            <a:prstDash val="solid"/>
+          </a:ln>
+        </p:spPr>
+      </p:sp>
+      <p:sp>
+        <p:nvSpPr>
+          <p:cNvPr id="15" name="Text 13"/>
+          <p:cNvSpPr txBox="1"/>
+          <p:nvPr/>
+        </p:nvSpPr>
+        <p:spPr>
+          <a:xfrm>
+            <a:off x="777240" y="4937760"/>
+            <a:ext cx="3063240" cy="411480"/>
+          </a:xfrm>
+          <a:prstGeom prst="rect">
+            <a:avLst/>
+          </a:prstGeom>
+          <a:noFill/>
+          <a:ln/>
+        </p:spPr>
+        <p:txBody>
+          <a:bodyPr wrap="square" lIns="0" tIns="0" rIns="0" bIns="0" rtlCol="0" anchor="ctr"/>
+          <a:lstStyle/>
+          <a:p>
+            <a:pPr indent="0" marL="0">
+              <a:buNone/>
+            </a:pPr>
+            <a:r>
+              <a:rPr lang="en-US" sz="1100" b="1" dirty="0">
+                <a:solidFill>
+                  <a:srgbClr val="4B5563"/>
+                </a:solidFill>
+                <a:latin typeface="Arial" pitchFamily="34" charset="0"/>
+                <a:ea typeface="Arial" pitchFamily="34" charset="-122"/>
+                <a:cs typeface="Arial" pitchFamily="34" charset="-120"/>
+              </a:rPr>
+              <a:t>Kosten  </a:t>
+            </a:r>
+            <a:pPr indent="0" marL="0">
+              <a:buNone/>
+            </a:pPr>
+            <a:r>
+              <a:rPr lang="en-US" sz="1800" b="1" dirty="0">
+                <a:solidFill>
+                  <a:srgbClr val="000E2F"/>
+                </a:solidFill>
+                <a:latin typeface="Arial" pitchFamily="34" charset="0"/>
+                <a:ea typeface="Arial" pitchFamily="34" charset="-122"/>
+                <a:cs typeface="Arial" pitchFamily="34" charset="-120"/>
+              </a:rPr>
+              <a:t>€€€€</a:t>
+            </a:r>
+            <a:pPr indent="0" marL="0">
+              <a:buNone/>
+            </a:pPr>
+            <a:endParaRPr lang="en-US" sz="1100" dirty="0"/>
+          </a:p>
+        </p:txBody>
+      </p:sp>
+      <p:sp>
+        <p:nvSpPr>
+          <p:cNvPr id="16" name="Shape 14"/>
+          <p:cNvSpPr/>
+          <p:nvPr/>
+        </p:nvSpPr>
+        <p:spPr>
+          <a:xfrm>
+            <a:off x="4335628" y="1645920"/>
+            <a:ext cx="3520440" cy="868680"/>
+          </a:xfrm>
+          <a:prstGeom prst="rect">
+            <a:avLst/>
+          </a:prstGeom>
+          <a:solidFill>
+            <a:srgbClr val="1B2D5C"/>
+          </a:solidFill>
+          <a:ln w="12700">
+            <a:solidFill>
+              <a:srgbClr val="1B2D5C"/>
+            </a:solidFill>
+            <a:prstDash val="solid"/>
+          </a:ln>
+        </p:spPr>
+      </p:sp>
+      <p:sp>
+        <p:nvSpPr>
+          <p:cNvPr id="17" name="Text 15"/>
+          <p:cNvSpPr txBox="1"/>
+          <p:nvPr/>
+        </p:nvSpPr>
+        <p:spPr>
+          <a:xfrm>
+            <a:off x="4564228" y="1737360"/>
+            <a:ext cx="3063240" cy="384048"/>
+          </a:xfrm>
+          <a:prstGeom prst="rect">
+            <a:avLst/>
+          </a:prstGeom>
+          <a:noFill/>
+          <a:ln/>
+        </p:spPr>
+        <p:txBody>
+          <a:bodyPr wrap="square" lIns="0" tIns="0" rIns="0" bIns="0" rtlCol="0" anchor="ctr"/>
+          <a:lstStyle/>
+          <a:p>
+            <a:pPr indent="0" marL="0">
+              <a:buNone/>
+            </a:pPr>
+            <a:r>
+              <a:rPr lang="en-US" sz="1600" b="1" dirty="0">
+                <a:solidFill>
+                  <a:srgbClr val="FFFFFF"/>
+                </a:solidFill>
+                <a:latin typeface="Arial" pitchFamily="34" charset="0"/>
+                <a:ea typeface="Arial" pitchFamily="34" charset="-122"/>
+                <a:cs typeface="Arial" pitchFamily="34" charset="-120"/>
+              </a:rPr>
+              <a:t>Centric PXM</a:t>
+            </a:r>
+            <a:endParaRPr lang="en-US" sz="1600" dirty="0"/>
+          </a:p>
+        </p:txBody>
+      </p:sp>
+      <p:sp>
+        <p:nvSpPr>
+          <p:cNvPr id="18" name="Text 16"/>
+          <p:cNvSpPr txBox="1"/>
+          <p:nvPr/>
+        </p:nvSpPr>
+        <p:spPr>
+          <a:xfrm>
+            <a:off x="4564228" y="2103120"/>
+            <a:ext cx="3063240" cy="365760"/>
+          </a:xfrm>
+          <a:prstGeom prst="rect">
+            <a:avLst/>
+          </a:prstGeom>
+          <a:noFill/>
+          <a:ln/>
+        </p:spPr>
+        <p:txBody>
+          <a:bodyPr wrap="square" lIns="0" tIns="0" rIns="0" bIns="0" rtlCol="0" anchor="t"/>
+          <a:lstStyle/>
+          <a:p>
+            <a:pPr indent="0" marL="0">
+              <a:buNone/>
+            </a:pPr>
+            <a:r>
+              <a:rPr lang="en-US" sz="1100" dirty="0">
+                <a:solidFill>
+                  <a:srgbClr val="C6E6E3"/>
+                </a:solidFill>
+                <a:latin typeface="Arial" pitchFamily="34" charset="0"/>
+                <a:ea typeface="Arial" pitchFamily="34" charset="-122"/>
+                <a:cs typeface="Arial" pitchFamily="34" charset="-120"/>
+              </a:rPr>
+              <a:t>ehem. Contentserv · seit 2025 bei Centric Software</a:t>
+            </a:r>
+            <a:endParaRPr lang="en-US" sz="1100" dirty="0"/>
+          </a:p>
+        </p:txBody>
+      </p:sp>
+      <p:sp>
+        <p:nvSpPr>
+          <p:cNvPr id="19" name="Shape 17"/>
+          <p:cNvSpPr/>
+          <p:nvPr/>
+        </p:nvSpPr>
+        <p:spPr>
+          <a:xfrm>
+            <a:off x="4335628" y="2514600"/>
+            <a:ext cx="3520440" cy="2880360"/>
+          </a:xfrm>
+          <a:prstGeom prst="rect">
+            <a:avLst/>
+          </a:prstGeom>
+          <a:solidFill>
+            <a:srgbClr val="FFFFFF"/>
+          </a:solidFill>
+          <a:ln w="12700">
+            <a:solidFill>
+              <a:srgbClr val="D6DDE3"/>
+            </a:solidFill>
+            <a:prstDash val="solid"/>
+          </a:ln>
+        </p:spPr>
+      </p:sp>
+      <p:sp>
+        <p:nvSpPr>
+          <p:cNvPr id="20" name="Text 18"/>
+          <p:cNvSpPr txBox="1"/>
+          <p:nvPr/>
+        </p:nvSpPr>
+        <p:spPr>
+          <a:xfrm>
+            <a:off x="4564228" y="2651760"/>
+            <a:ext cx="3063240" cy="228600"/>
+          </a:xfrm>
+          <a:prstGeom prst="rect">
+            <a:avLst/>
+          </a:prstGeom>
+          <a:noFill/>
+          <a:ln/>
+        </p:spPr>
+        <p:txBody>
+          <a:bodyPr wrap="square" lIns="0" tIns="0" rIns="0" bIns="0" rtlCol="0" anchor="t"/>
+          <a:lstStyle/>
+          <a:p>
+            <a:pPr indent="0" marL="0">
+              <a:buNone/>
+            </a:pPr>
+            <a:r>
+              <a:rPr lang="en-US" sz="1000" b="1" spc="100" kern="0" dirty="0">
+                <a:solidFill>
+                  <a:srgbClr val="4B5563"/>
+                </a:solidFill>
+                <a:latin typeface="Arial" pitchFamily="34" charset="0"/>
+                <a:ea typeface="Arial" pitchFamily="34" charset="-122"/>
+                <a:cs typeface="Arial" pitchFamily="34" charset="-120"/>
+              </a:rPr>
+              <a:t>EINSCHÄTZUNG</a:t>
+            </a:r>
+            <a:endParaRPr lang="en-US" sz="1000" dirty="0"/>
+          </a:p>
+        </p:txBody>
+      </p:sp>
+      <p:sp>
+        <p:nvSpPr>
+          <p:cNvPr id="21" name="Text 19"/>
+          <p:cNvSpPr txBox="1"/>
+          <p:nvPr/>
+        </p:nvSpPr>
+        <p:spPr>
+          <a:xfrm>
+            <a:off x="4564228" y="2907792"/>
+            <a:ext cx="3063240" cy="960120"/>
+          </a:xfrm>
+          <a:prstGeom prst="rect">
+            <a:avLst/>
+          </a:prstGeom>
+          <a:noFill/>
+          <a:ln/>
+        </p:spPr>
+        <p:txBody>
+          <a:bodyPr wrap="square" lIns="0" tIns="0" rIns="0" bIns="0" rtlCol="0" anchor="t"/>
+          <a:lstStyle/>
+          <a:p>
+            <a:pPr indent="0" marL="0">
+              <a:lnSpc>
+                <a:spcPct val="108000"/>
+              </a:lnSpc>
+              <a:buNone/>
+            </a:pPr>
+            <a:r>
+              <a:rPr lang="en-US" sz="1200" dirty="0">
+                <a:solidFill>
+                  <a:srgbClr val="16181D"/>
+                </a:solidFill>
+                <a:latin typeface="Arial" pitchFamily="34" charset="0"/>
+                <a:ea typeface="Arial" pitchFamily="34" charset="-122"/>
+                <a:cs typeface="Arial" pitchFamily="34" charset="-120"/>
+              </a:rPr>
+              <a:t>Enterprise-PIM mit Schwerpunkt Marketing-Content, Medien und Publishing; eingebettet in die Centric-Produktfamilie (PLM, Planung).</a:t>
+            </a:r>
+            <a:endParaRPr lang="en-US" sz="1200" dirty="0"/>
+          </a:p>
+        </p:txBody>
+      </p:sp>
+      <p:sp>
+        <p:nvSpPr>
+          <p:cNvPr id="22" name="Text 20"/>
+          <p:cNvSpPr txBox="1"/>
+          <p:nvPr/>
+        </p:nvSpPr>
+        <p:spPr>
+          <a:xfrm>
+            <a:off x="4564228" y="3913632"/>
+            <a:ext cx="3063240" cy="228600"/>
+          </a:xfrm>
+          <a:prstGeom prst="rect">
+            <a:avLst/>
+          </a:prstGeom>
+          <a:noFill/>
+          <a:ln/>
+        </p:spPr>
+        <p:txBody>
+          <a:bodyPr wrap="square" lIns="0" tIns="0" rIns="0" bIns="0" rtlCol="0" anchor="t"/>
+          <a:lstStyle/>
+          <a:p>
+            <a:pPr indent="0" marL="0">
+              <a:buNone/>
+            </a:pPr>
+            <a:r>
+              <a:rPr lang="en-US" sz="1000" b="1" spc="100" kern="0" dirty="0">
+                <a:solidFill>
+                  <a:srgbClr val="4B5563"/>
+                </a:solidFill>
+                <a:latin typeface="Arial" pitchFamily="34" charset="0"/>
+                <a:ea typeface="Arial" pitchFamily="34" charset="-122"/>
+                <a:cs typeface="Arial" pitchFamily="34" charset="-120"/>
+              </a:rPr>
+              <a:t>PASSUNG FÜR KOHLHAMMER</a:t>
+            </a:r>
+            <a:endParaRPr lang="en-US" sz="1000" dirty="0"/>
+          </a:p>
+        </p:txBody>
+      </p:sp>
+      <p:sp>
+        <p:nvSpPr>
+          <p:cNvPr id="23" name="Text 21"/>
+          <p:cNvSpPr txBox="1"/>
+          <p:nvPr/>
+        </p:nvSpPr>
+        <p:spPr>
+          <a:xfrm>
+            <a:off x="4564228" y="4169664"/>
+            <a:ext cx="3063240" cy="685800"/>
+          </a:xfrm>
+          <a:prstGeom prst="rect">
+            <a:avLst/>
+          </a:prstGeom>
+          <a:noFill/>
+          <a:ln/>
+        </p:spPr>
+        <p:txBody>
+          <a:bodyPr wrap="square" lIns="0" tIns="0" rIns="0" bIns="0" rtlCol="0" anchor="t"/>
+          <a:lstStyle/>
+          <a:p>
+            <a:pPr indent="0" marL="0">
+              <a:lnSpc>
+                <a:spcPct val="108000"/>
+              </a:lnSpc>
+              <a:buNone/>
+            </a:pPr>
+            <a:r>
+              <a:rPr lang="en-US" sz="1200" dirty="0">
+                <a:solidFill>
+                  <a:srgbClr val="16181D"/>
+                </a:solidFill>
+                <a:latin typeface="Arial" pitchFamily="34" charset="0"/>
+                <a:ea typeface="Arial" pitchFamily="34" charset="-122"/>
+                <a:cs typeface="Arial" pitchFamily="34" charset="-120"/>
+              </a:rPr>
+              <a:t>Passend bei hohem Marketing- und Print-Anteil; Kosten und Einführung auf Enterprise-Niveau.</a:t>
+            </a:r>
+            <a:endParaRPr lang="en-US" sz="1200" dirty="0"/>
+          </a:p>
+        </p:txBody>
+      </p:sp>
+      <p:sp>
+        <p:nvSpPr>
+          <p:cNvPr id="24" name="Shape 22"/>
+          <p:cNvSpPr/>
+          <p:nvPr/>
+        </p:nvSpPr>
+        <p:spPr>
+          <a:xfrm>
+            <a:off x="4564228" y="4892040"/>
+            <a:ext cx="3063240" cy="0"/>
+          </a:xfrm>
+          <a:prstGeom prst="line">
+            <a:avLst/>
+          </a:prstGeom>
+          <a:noFill/>
+          <a:ln w="12700">
+            <a:solidFill>
+              <a:srgbClr val="D6DDE3"/>
+            </a:solidFill>
+            <a:prstDash val="solid"/>
+          </a:ln>
+        </p:spPr>
+      </p:sp>
+      <p:sp>
+        <p:nvSpPr>
+          <p:cNvPr id="25" name="Text 23"/>
+          <p:cNvSpPr txBox="1"/>
+          <p:nvPr/>
+        </p:nvSpPr>
+        <p:spPr>
+          <a:xfrm>
+            <a:off x="4564228" y="4937760"/>
+            <a:ext cx="3063240" cy="411480"/>
+          </a:xfrm>
+          <a:prstGeom prst="rect">
+            <a:avLst/>
+          </a:prstGeom>
+          <a:noFill/>
+          <a:ln/>
+        </p:spPr>
+        <p:txBody>
+          <a:bodyPr wrap="square" lIns="0" tIns="0" rIns="0" bIns="0" rtlCol="0" anchor="ctr"/>
+          <a:lstStyle/>
+          <a:p>
+            <a:pPr indent="0" marL="0">
+              <a:buNone/>
+            </a:pPr>
+            <a:r>
+              <a:rPr lang="en-US" sz="1100" b="1" dirty="0">
+                <a:solidFill>
+                  <a:srgbClr val="4B5563"/>
+                </a:solidFill>
+                <a:latin typeface="Arial" pitchFamily="34" charset="0"/>
+                <a:ea typeface="Arial" pitchFamily="34" charset="-122"/>
+                <a:cs typeface="Arial" pitchFamily="34" charset="-120"/>
+              </a:rPr>
+              <a:t>Kosten  </a:t>
+            </a:r>
+            <a:pPr indent="0" marL="0">
+              <a:buNone/>
+            </a:pPr>
+            <a:r>
+              <a:rPr lang="en-US" sz="1800" b="1" dirty="0">
+                <a:solidFill>
+                  <a:srgbClr val="000E2F"/>
+                </a:solidFill>
+                <a:latin typeface="Arial" pitchFamily="34" charset="0"/>
+                <a:ea typeface="Arial" pitchFamily="34" charset="-122"/>
+                <a:cs typeface="Arial" pitchFamily="34" charset="-120"/>
+              </a:rPr>
+              <a:t>€€€</a:t>
+            </a:r>
+            <a:pPr indent="0" marL="0">
+              <a:buNone/>
+            </a:pPr>
+            <a:r>
+              <a:rPr lang="en-US" sz="1800" b="1" dirty="0">
+                <a:solidFill>
+                  <a:srgbClr val="D0D5DB"/>
+                </a:solidFill>
+                <a:latin typeface="Arial" pitchFamily="34" charset="0"/>
+                <a:ea typeface="Arial" pitchFamily="34" charset="-122"/>
+                <a:cs typeface="Arial" pitchFamily="34" charset="-120"/>
+              </a:rPr>
+              <a:t>€</a:t>
+            </a:r>
+            <a:endParaRPr lang="en-US" sz="1100" dirty="0"/>
+          </a:p>
+        </p:txBody>
+      </p:sp>
+      <p:sp>
+        <p:nvSpPr>
+          <p:cNvPr id="26" name="Shape 24"/>
+          <p:cNvSpPr/>
+          <p:nvPr/>
+        </p:nvSpPr>
+        <p:spPr>
+          <a:xfrm>
+            <a:off x="8122615" y="1645920"/>
+            <a:ext cx="3520440" cy="868680"/>
+          </a:xfrm>
+          <a:prstGeom prst="rect">
+            <a:avLst/>
+          </a:prstGeom>
+          <a:solidFill>
+            <a:srgbClr val="1B2D5C"/>
+          </a:solidFill>
+          <a:ln w="12700">
+            <a:solidFill>
+              <a:srgbClr val="1B2D5C"/>
+            </a:solidFill>
+            <a:prstDash val="solid"/>
+          </a:ln>
+        </p:spPr>
+      </p:sp>
+      <p:sp>
+        <p:nvSpPr>
+          <p:cNvPr id="27" name="Text 25"/>
+          <p:cNvSpPr txBox="1"/>
+          <p:nvPr/>
+        </p:nvSpPr>
+        <p:spPr>
+          <a:xfrm>
+            <a:off x="8351215" y="1737360"/>
+            <a:ext cx="3063240" cy="384048"/>
+          </a:xfrm>
+          <a:prstGeom prst="rect">
+            <a:avLst/>
+          </a:prstGeom>
+          <a:noFill/>
+          <a:ln/>
+        </p:spPr>
+        <p:txBody>
+          <a:bodyPr wrap="square" lIns="0" tIns="0" rIns="0" bIns="0" rtlCol="0" anchor="ctr"/>
+          <a:lstStyle/>
+          <a:p>
+            <a:pPr indent="0" marL="0">
+              <a:buNone/>
+            </a:pPr>
+            <a:r>
+              <a:rPr lang="en-US" sz="1600" b="1" dirty="0">
+                <a:solidFill>
+                  <a:srgbClr val="FFFFFF"/>
+                </a:solidFill>
+                <a:latin typeface="Arial" pitchFamily="34" charset="0"/>
+                <a:ea typeface="Arial" pitchFamily="34" charset="-122"/>
+                <a:cs typeface="Arial" pitchFamily="34" charset="-120"/>
+              </a:rPr>
+              <a:t>Akeneo</a:t>
+            </a:r>
+            <a:endParaRPr lang="en-US" sz="1600" dirty="0"/>
+          </a:p>
+        </p:txBody>
+      </p:sp>
+      <p:sp>
+        <p:nvSpPr>
+          <p:cNvPr id="28" name="Text 26"/>
+          <p:cNvSpPr txBox="1"/>
+          <p:nvPr/>
+        </p:nvSpPr>
+        <p:spPr>
+          <a:xfrm>
+            <a:off x="8351215" y="2103120"/>
+            <a:ext cx="3063240" cy="365760"/>
+          </a:xfrm>
+          <a:prstGeom prst="rect">
+            <a:avLst/>
+          </a:prstGeom>
+          <a:noFill/>
+          <a:ln/>
+        </p:spPr>
+        <p:txBody>
+          <a:bodyPr wrap="square" lIns="0" tIns="0" rIns="0" bIns="0" rtlCol="0" anchor="t"/>
+          <a:lstStyle/>
+          <a:p>
+            <a:pPr indent="0" marL="0">
+              <a:buNone/>
+            </a:pPr>
+            <a:r>
+              <a:rPr lang="en-US" sz="1100" dirty="0">
+                <a:solidFill>
+                  <a:srgbClr val="C6E6E3"/>
+                </a:solidFill>
+                <a:latin typeface="Arial" pitchFamily="34" charset="0"/>
+                <a:ea typeface="Arial" pitchFamily="34" charset="-122"/>
+                <a:cs typeface="Arial" pitchFamily="34" charset="-120"/>
+              </a:rPr>
+              <a:t>SaaS-PIM mit freier Community Edition</a:t>
+            </a:r>
+            <a:endParaRPr lang="en-US" sz="1100" dirty="0"/>
+          </a:p>
+        </p:txBody>
+      </p:sp>
+      <p:sp>
+        <p:nvSpPr>
+          <p:cNvPr id="29" name="Shape 27"/>
+          <p:cNvSpPr/>
+          <p:nvPr/>
+        </p:nvSpPr>
+        <p:spPr>
+          <a:xfrm>
+            <a:off x="8122615" y="2514600"/>
+            <a:ext cx="3520440" cy="2880360"/>
+          </a:xfrm>
+          <a:prstGeom prst="rect">
+            <a:avLst/>
+          </a:prstGeom>
+          <a:solidFill>
+            <a:srgbClr val="FFFFFF"/>
+          </a:solidFill>
+          <a:ln w="12700">
+            <a:solidFill>
+              <a:srgbClr val="D6DDE3"/>
+            </a:solidFill>
+            <a:prstDash val="solid"/>
+          </a:ln>
+        </p:spPr>
+      </p:sp>
+      <p:sp>
+        <p:nvSpPr>
+          <p:cNvPr id="30" name="Text 28"/>
+          <p:cNvSpPr txBox="1"/>
+          <p:nvPr/>
+        </p:nvSpPr>
+        <p:spPr>
+          <a:xfrm>
+            <a:off x="8351215" y="2651760"/>
+            <a:ext cx="3063240" cy="228600"/>
+          </a:xfrm>
+          <a:prstGeom prst="rect">
+            <a:avLst/>
+          </a:prstGeom>
+          <a:noFill/>
+          <a:ln/>
+        </p:spPr>
+        <p:txBody>
+          <a:bodyPr wrap="square" lIns="0" tIns="0" rIns="0" bIns="0" rtlCol="0" anchor="t"/>
+          <a:lstStyle/>
+          <a:p>
+            <a:pPr indent="0" marL="0">
+              <a:buNone/>
+            </a:pPr>
+            <a:r>
+              <a:rPr lang="en-US" sz="1000" b="1" spc="100" kern="0" dirty="0">
+                <a:solidFill>
+                  <a:srgbClr val="4B5563"/>
+                </a:solidFill>
+                <a:latin typeface="Arial" pitchFamily="34" charset="0"/>
+                <a:ea typeface="Arial" pitchFamily="34" charset="-122"/>
+                <a:cs typeface="Arial" pitchFamily="34" charset="-120"/>
+              </a:rPr>
+              <a:t>EINSCHÄTZUNG</a:t>
+            </a:r>
+            <a:endParaRPr lang="en-US" sz="1000" dirty="0"/>
+          </a:p>
+        </p:txBody>
+      </p:sp>
+      <p:sp>
+        <p:nvSpPr>
+          <p:cNvPr id="31" name="Text 29"/>
+          <p:cNvSpPr txBox="1"/>
+          <p:nvPr/>
+        </p:nvSpPr>
+        <p:spPr>
+          <a:xfrm>
+            <a:off x="8351215" y="2907792"/>
+            <a:ext cx="3063240" cy="960120"/>
+          </a:xfrm>
+          <a:prstGeom prst="rect">
+            <a:avLst/>
+          </a:prstGeom>
+          <a:noFill/>
+          <a:ln/>
+        </p:spPr>
+        <p:txBody>
+          <a:bodyPr wrap="square" lIns="0" tIns="0" rIns="0" bIns="0" rtlCol="0" anchor="t"/>
+          <a:lstStyle/>
+          <a:p>
+            <a:pPr indent="0" marL="0">
+              <a:lnSpc>
+                <a:spcPct val="108000"/>
+              </a:lnSpc>
+              <a:buNone/>
+            </a:pPr>
+            <a:r>
+              <a:rPr lang="en-US" sz="1200" dirty="0">
+                <a:solidFill>
+                  <a:srgbClr val="16181D"/>
+                </a:solidFill>
+                <a:latin typeface="Arial" pitchFamily="34" charset="0"/>
+                <a:ea typeface="Arial" pitchFamily="34" charset="-122"/>
+                <a:cs typeface="Arial" pitchFamily="34" charset="-120"/>
+              </a:rPr>
+              <a:t>Stark in der Anreicherung für E-Commerce und Marktplätze; großes Partner- und App-Ökosystem, cloudbasiert.</a:t>
+            </a:r>
+            <a:endParaRPr lang="en-US" sz="1200" dirty="0"/>
+          </a:p>
+        </p:txBody>
+      </p:sp>
+      <p:sp>
+        <p:nvSpPr>
+          <p:cNvPr id="32" name="Text 30"/>
+          <p:cNvSpPr txBox="1"/>
+          <p:nvPr/>
+        </p:nvSpPr>
+        <p:spPr>
+          <a:xfrm>
+            <a:off x="8351215" y="3913632"/>
+            <a:ext cx="3063240" cy="228600"/>
+          </a:xfrm>
+          <a:prstGeom prst="rect">
+            <a:avLst/>
+          </a:prstGeom>
+          <a:noFill/>
+          <a:ln/>
+        </p:spPr>
+        <p:txBody>
+          <a:bodyPr wrap="square" lIns="0" tIns="0" rIns="0" bIns="0" rtlCol="0" anchor="t"/>
+          <a:lstStyle/>
+          <a:p>
+            <a:pPr indent="0" marL="0">
+              <a:buNone/>
+            </a:pPr>
+            <a:r>
+              <a:rPr lang="en-US" sz="1000" b="1" spc="100" kern="0" dirty="0">
+                <a:solidFill>
+                  <a:srgbClr val="4B5563"/>
+                </a:solidFill>
+                <a:latin typeface="Arial" pitchFamily="34" charset="0"/>
+                <a:ea typeface="Arial" pitchFamily="34" charset="-122"/>
+                <a:cs typeface="Arial" pitchFamily="34" charset="-120"/>
+              </a:rPr>
+              <a:t>PASSUNG FÜR KOHLHAMMER</a:t>
+            </a:r>
+            <a:endParaRPr lang="en-US" sz="1000" dirty="0"/>
+          </a:p>
+        </p:txBody>
+      </p:sp>
+      <p:sp>
+        <p:nvSpPr>
+          <p:cNvPr id="33" name="Text 31"/>
+          <p:cNvSpPr txBox="1"/>
+          <p:nvPr/>
+        </p:nvSpPr>
+        <p:spPr>
+          <a:xfrm>
+            <a:off x="8351215" y="4169664"/>
+            <a:ext cx="3063240" cy="685800"/>
+          </a:xfrm>
+          <a:prstGeom prst="rect">
+            <a:avLst/>
+          </a:prstGeom>
+          <a:noFill/>
+          <a:ln/>
+        </p:spPr>
+        <p:txBody>
+          <a:bodyPr wrap="square" lIns="0" tIns="0" rIns="0" bIns="0" rtlCol="0" anchor="t"/>
+          <a:lstStyle/>
+          <a:p>
+            <a:pPr indent="0" marL="0">
+              <a:lnSpc>
+                <a:spcPct val="108000"/>
+              </a:lnSpc>
+              <a:buNone/>
+            </a:pPr>
+            <a:r>
+              <a:rPr lang="en-US" sz="1200" dirty="0">
+                <a:solidFill>
+                  <a:srgbClr val="16181D"/>
+                </a:solidFill>
+                <a:latin typeface="Arial" pitchFamily="34" charset="0"/>
+                <a:ea typeface="Arial" pitchFamily="34" charset="-122"/>
+                <a:cs typeface="Arial" pitchFamily="34" charset="-120"/>
+              </a:rPr>
+              <a:t>Gut für digitale Kanäle; Print- und Verlagsanforderungen meist über Erweiterungen oder Projektarbeit.</a:t>
+            </a:r>
+            <a:endParaRPr lang="en-US" sz="1200" dirty="0"/>
+          </a:p>
+        </p:txBody>
+      </p:sp>
+      <p:sp>
+        <p:nvSpPr>
+          <p:cNvPr id="34" name="Shape 32"/>
+          <p:cNvSpPr/>
+          <p:nvPr/>
+        </p:nvSpPr>
+        <p:spPr>
+          <a:xfrm>
+            <a:off x="8351215" y="4892040"/>
+            <a:ext cx="3063240" cy="0"/>
+          </a:xfrm>
+          <a:prstGeom prst="line">
+            <a:avLst/>
+          </a:prstGeom>
+          <a:noFill/>
+          <a:ln w="12700">
+            <a:solidFill>
+              <a:srgbClr val="D6DDE3"/>
+            </a:solidFill>
+            <a:prstDash val="solid"/>
+          </a:ln>
+        </p:spPr>
+      </p:sp>
+      <p:sp>
+        <p:nvSpPr>
+          <p:cNvPr id="35" name="Text 33"/>
+          <p:cNvSpPr txBox="1"/>
+          <p:nvPr/>
+        </p:nvSpPr>
+        <p:spPr>
+          <a:xfrm>
+            <a:off x="8351215" y="4937760"/>
+            <a:ext cx="3063240" cy="411480"/>
+          </a:xfrm>
+          <a:prstGeom prst="rect">
+            <a:avLst/>
+          </a:prstGeom>
+          <a:noFill/>
+          <a:ln/>
+        </p:spPr>
+        <p:txBody>
+          <a:bodyPr wrap="square" lIns="0" tIns="0" rIns="0" bIns="0" rtlCol="0" anchor="ctr"/>
+          <a:lstStyle/>
+          <a:p>
+            <a:pPr indent="0" marL="0">
+              <a:buNone/>
+            </a:pPr>
+            <a:r>
+              <a:rPr lang="en-US" sz="1100" b="1" dirty="0">
+                <a:solidFill>
+                  <a:srgbClr val="4B5563"/>
+                </a:solidFill>
+                <a:latin typeface="Arial" pitchFamily="34" charset="0"/>
+                <a:ea typeface="Arial" pitchFamily="34" charset="-122"/>
+                <a:cs typeface="Arial" pitchFamily="34" charset="-120"/>
+              </a:rPr>
+              <a:t>Kosten  </a:t>
+            </a:r>
+            <a:pPr indent="0" marL="0">
+              <a:buNone/>
+            </a:pPr>
+            <a:r>
+              <a:rPr lang="en-US" sz="1800" b="1" dirty="0">
+                <a:solidFill>
+                  <a:srgbClr val="000E2F"/>
+                </a:solidFill>
+                <a:latin typeface="Arial" pitchFamily="34" charset="0"/>
+                <a:ea typeface="Arial" pitchFamily="34" charset="-122"/>
+                <a:cs typeface="Arial" pitchFamily="34" charset="-120"/>
+              </a:rPr>
+              <a:t>€€</a:t>
+            </a:r>
+            <a:pPr indent="0" marL="0">
+              <a:buNone/>
+            </a:pPr>
+            <a:r>
+              <a:rPr lang="en-US" sz="1800" b="1" dirty="0">
+                <a:solidFill>
+                  <a:srgbClr val="D0D5DB"/>
+                </a:solidFill>
+                <a:latin typeface="Arial" pitchFamily="34" charset="0"/>
+                <a:ea typeface="Arial" pitchFamily="34" charset="-122"/>
+                <a:cs typeface="Arial" pitchFamily="34" charset="-120"/>
+              </a:rPr>
+              <a:t>€€</a:t>
+            </a:r>
+            <a:endParaRPr lang="en-US" sz="1100" dirty="0"/>
+          </a:p>
+        </p:txBody>
+      </p:sp>
+      <p:sp>
+        <p:nvSpPr>
+          <p:cNvPr id="36" name="Text 34"/>
+          <p:cNvSpPr txBox="1"/>
+          <p:nvPr/>
+        </p:nvSpPr>
+        <p:spPr>
+          <a:xfrm>
+            <a:off x="548640" y="5532120"/>
+            <a:ext cx="11094415" cy="457200"/>
+          </a:xfrm>
+          <a:prstGeom prst="rect">
+            <a:avLst/>
+          </a:prstGeom>
+          <a:noFill/>
+          <a:ln/>
+        </p:spPr>
+        <p:txBody>
+          <a:bodyPr wrap="square" lIns="0" tIns="0" rIns="0" bIns="0" rtlCol="0" anchor="t"/>
+          <a:lstStyle/>
+          <a:p>
+            <a:pPr indent="0" marL="0">
+              <a:buNone/>
+            </a:pPr>
+            <a:r>
+              <a:rPr lang="en-US" sz="1000" i="1" dirty="0">
+                <a:solidFill>
+                  <a:srgbClr val="4B5563"/>
+                </a:solidFill>
+                <a:latin typeface="Arial" pitchFamily="34" charset="0"/>
+                <a:ea typeface="Arial" pitchFamily="34" charset="-122"/>
+                <a:cs typeface="Arial" pitchFamily="34" charset="-120"/>
+              </a:rPr>
+              <a:t>Kosten als grobe Größenordnung für Lizenz bzw. Abonnement plus Einführung (€ gering bis €€€€ sehr hoch) – ohne Gewähr, abhängig von Umfang und Angebot. Akeneo Growth laut Drittquellen ab ca. 25.000 € pro Jahr; Stibo und Centric PXM nur auf Anfrage.</a:t>
+            </a:r>
+            <a:endParaRPr lang="en-US" sz="1000" dirty="0"/>
+          </a:p>
+        </p:txBody>
+      </p:sp>
+      <p:sp>
+        <p:nvSpPr>
+          <p:cNvPr id="37" name="Text 35"/>
+          <p:cNvSpPr txBox="1"/>
+          <p:nvPr/>
+        </p:nvSpPr>
+        <p:spPr>
+          <a:xfrm>
+            <a:off x="548640" y="5989320"/>
+            <a:ext cx="11094415" cy="274320"/>
+          </a:xfrm>
+          <a:prstGeom prst="rect">
+            <a:avLst/>
+          </a:prstGeom>
+          <a:noFill/>
+          <a:ln/>
+        </p:spPr>
+        <p:txBody>
+          <a:bodyPr wrap="square" lIns="0" tIns="0" rIns="0" bIns="0" rtlCol="0" anchor="t"/>
+          <a:lstStyle/>
+          <a:p>
+            <a:pPr indent="0" marL="0">
+              <a:buNone/>
+            </a:pPr>
+            <a:r>
+              <a:rPr lang="en-US" sz="900" dirty="0">
+                <a:solidFill>
+                  <a:srgbClr val="4B5563"/>
+                </a:solidFill>
+                <a:latin typeface="Arial" pitchFamily="34" charset="0"/>
+                <a:ea typeface="Arial" pitchFamily="34" charset="-122"/>
+                <a:cs typeface="Arial" pitchFamily="34" charset="-120"/>
+              </a:rPr>
+              <a:t>Quellen: Centric Software / Dassault Systèmes, Pressemitteilung zur Übernahme von Contentserv (Februar 2025); akeneo.com; OMR Reviews (Akeneo-Preise).</a:t>
+            </a:r>
+            <a:endParaRPr lang="en-US" sz="900" dirty="0"/>
+          </a:p>
+        </p:txBody>
+      </p:sp>
+    </p:spTree>
+  </p:cSld>
+  <p:clrMapOvr>
+    <a:masterClrMapping/>
+  </p:clrMapOvr>
+</p:sld>
+</file>
+
 <file path=ppt/slides/slide2.xml><?xml version="1.0" encoding="utf-8"?>
 <p:sld xmlns:a="http://schemas.openxmlformats.org/drawingml/2006/main" xmlns:r="http://schemas.openxmlformats.org/officeDocument/2006/relationships" xmlns:p="http://schemas.openxmlformats.org/presentationml/2006/main">
   <p:cSld name="Slide 2">

</xml_diff>